<commit_message>
Add Buildathon team context to materials
Co-authored-by: Shyam <shyam.nexus@gmail.com>
</commit_message>
<xml_diff>
--- a/AI-Driven Embedded Product Lifecycle OrchestratorV3.pptx
+++ b/AI-Driven Embedded Product Lifecycle OrchestratorV3.pptx
@@ -12808,14 +12808,49 @@
                 </a:solidFill>
                 <a:latin typeface="Segoe UI"/>
               </a:rPr>
-              <a:t>May 2026   |   CONFIDENTIAL</a:t>
+              <a:t>Honeywell BA Buildathon | 17 Jun 2026 | CONFIDENTIAL</a:t>
             </a:r>
           </a:p>
         </p:txBody>
       </p:sp>
       <p:sp>
         <p:nvSpPr>
-          <p:cNvPr id="229" name="Rectangle 228"/>
+          <p:cNvPr id="229" name="TextBox 228"/>
+          <p:cNvSpPr txBox="1"/>
+          <p:nvPr/>
+        </p:nvSpPr>
+        <p:spPr>
+          <a:xfrm>
+            <a:off x="256032" y="5193792"/>
+            <a:ext cx="5669280" cy="256032"/>
+          </a:xfrm>
+          <a:prstGeom prst="rect">
+            <a:avLst/>
+          </a:prstGeom>
+          <a:noFill/>
+        </p:spPr>
+        <p:txBody>
+          <a:bodyPr wrap="square">
+            <a:spAutoFit/>
+          </a:bodyPr>
+          <a:lstStyle/>
+          <a:p>
+            <a:pPr algn="l"/>
+            <a:r>
+              <a:rPr sz="880" b="0" i="0">
+                <a:solidFill>
+                  <a:srgbClr val="B8D0EC"/>
+                </a:solidFill>
+                <a:latin typeface="Segoe UI"/>
+              </a:rPr>
+              <a:t>Presenter: Shyam Shrivastava, Project Lead | Team: Atharva, Manas, Sheraaz</a:t>
+            </a:r>
+          </a:p>
+        </p:txBody>
+      </p:sp>
+      <p:sp>
+        <p:nvSpPr>
+          <p:cNvPr id="230" name="Rectangle 229"/>
           <p:cNvSpPr/>
           <p:nvPr/>
         </p:nvSpPr>
@@ -12858,7 +12893,7 @@
       </p:sp>
       <p:sp>
         <p:nvSpPr>
-          <p:cNvPr id="230" name="Rectangle 229"/>
+          <p:cNvPr id="231" name="Rectangle 230"/>
           <p:cNvSpPr/>
           <p:nvPr/>
         </p:nvSpPr>
@@ -12901,7 +12936,7 @@
       </p:sp>
       <p:sp>
         <p:nvSpPr>
-          <p:cNvPr id="231" name="Rectangle 230"/>
+          <p:cNvPr id="232" name="Rectangle 231"/>
           <p:cNvSpPr/>
           <p:nvPr/>
         </p:nvSpPr>
@@ -12944,7 +12979,7 @@
       </p:sp>
       <p:sp>
         <p:nvSpPr>
-          <p:cNvPr id="232" name="Rectangle 231"/>
+          <p:cNvPr id="233" name="Rectangle 232"/>
           <p:cNvSpPr/>
           <p:nvPr/>
         </p:nvSpPr>
@@ -12987,7 +13022,7 @@
       </p:sp>
       <p:sp>
         <p:nvSpPr>
-          <p:cNvPr id="233" name="TextBox 232"/>
+          <p:cNvPr id="234" name="TextBox 233"/>
           <p:cNvSpPr txBox="1"/>
           <p:nvPr/>
         </p:nvSpPr>

</xml_diff>

<commit_message>
Regenerate deck with criteria matrix slide
Co-authored-by: Shyam <shyam.nexus@gmail.com>
</commit_message>
<xml_diff>
--- a/AI-Driven Embedded Product Lifecycle OrchestratorV3.pptx
+++ b/AI-Driven Embedded Product Lifecycle OrchestratorV3.pptx
@@ -17,6 +17,7 @@
     <p:sldId id="265" r:id="rId16"/>
     <p:sldId id="266" r:id="rId17"/>
     <p:sldId id="267" r:id="rId18"/>
+    <p:sldId id="268" r:id="rId19"/>
   </p:sldIdLst>
   <p:sldSz cx="9144000" cy="6858000" type="screen4x3"/>
   <p:notesSz cx="6858000" cy="9144000"/>
@@ -13050,7 +13051,7 @@
                 </a:solidFill>
                 <a:latin typeface="Segoe UI"/>
               </a:rPr>
-              <a:t>1  /  12</a:t>
+              <a:t>1  /  13</a:t>
             </a:r>
           </a:p>
         </p:txBody>
@@ -14927,7 +14928,7 @@
                 </a:solidFill>
                 <a:latin typeface="Segoe UI"/>
               </a:rPr>
-              <a:t>10  /  12</a:t>
+              <a:t>10  /  13</a:t>
             </a:r>
           </a:p>
         </p:txBody>
@@ -16692,7 +16693,7 @@
                 </a:solidFill>
                 <a:latin typeface="Segoe UI"/>
               </a:rPr>
-              <a:t>11  /  12</a:t>
+              <a:t>11  /  13</a:t>
             </a:r>
           </a:p>
         </p:txBody>
@@ -16803,6 +16804,2138 @@
       </p:sp>
       <p:sp>
         <p:nvSpPr>
+          <p:cNvPr id="4" name="Rounded Rectangle 3"/>
+          <p:cNvSpPr/>
+          <p:nvPr/>
+        </p:nvSpPr>
+        <p:spPr>
+          <a:xfrm>
+            <a:off x="347472" y="438912"/>
+            <a:ext cx="2011680" cy="274320"/>
+          </a:xfrm>
+          <a:prstGeom prst="roundRect">
+            <a:avLst/>
+          </a:prstGeom>
+          <a:solidFill>
+            <a:srgbClr val="00C8F0"/>
+          </a:solidFill>
+          <a:ln>
+            <a:noFill/>
+          </a:ln>
+        </p:spPr>
+        <p:style>
+          <a:lnRef idx="1">
+            <a:schemeClr val="accent1"/>
+          </a:lnRef>
+          <a:fillRef idx="3">
+            <a:schemeClr val="accent1"/>
+          </a:fillRef>
+          <a:effectRef idx="2">
+            <a:schemeClr val="accent1"/>
+          </a:effectRef>
+          <a:fontRef idx="minor">
+            <a:schemeClr val="lt1"/>
+          </a:fontRef>
+        </p:style>
+        <p:txBody>
+          <a:bodyPr rtlCol="0" anchor="ctr"/>
+          <a:lstStyle/>
+          <a:p>
+            <a:pPr algn="ctr"/>
+          </a:p>
+        </p:txBody>
+      </p:sp>
+      <p:sp>
+        <p:nvSpPr>
+          <p:cNvPr id="5" name="TextBox 4"/>
+          <p:cNvSpPr txBox="1"/>
+          <p:nvPr/>
+        </p:nvSpPr>
+        <p:spPr>
+          <a:xfrm>
+            <a:off x="347472" y="438912"/>
+            <a:ext cx="2011680" cy="274320"/>
+          </a:xfrm>
+          <a:prstGeom prst="rect">
+            <a:avLst/>
+          </a:prstGeom>
+          <a:noFill/>
+        </p:spPr>
+        <p:txBody>
+          <a:bodyPr wrap="square">
+            <a:spAutoFit/>
+          </a:bodyPr>
+          <a:lstStyle/>
+          <a:p>
+            <a:pPr algn="ctr"/>
+            <a:r>
+              <a:rPr sz="900" b="1" i="0">
+                <a:solidFill>
+                  <a:srgbClr val="FFFFFF"/>
+                </a:solidFill>
+                <a:latin typeface="Segoe UI"/>
+              </a:rPr>
+              <a:t>EVALUATION MATRIX</a:t>
+            </a:r>
+          </a:p>
+        </p:txBody>
+      </p:sp>
+      <p:sp>
+        <p:nvSpPr>
+          <p:cNvPr id="6" name="TextBox 5"/>
+          <p:cNvSpPr txBox="1"/>
+          <p:nvPr/>
+        </p:nvSpPr>
+        <p:spPr>
+          <a:xfrm>
+            <a:off x="347472" y="749808"/>
+            <a:ext cx="8229600" cy="530352"/>
+          </a:xfrm>
+          <a:prstGeom prst="rect">
+            <a:avLst/>
+          </a:prstGeom>
+          <a:noFill/>
+        </p:spPr>
+        <p:txBody>
+          <a:bodyPr wrap="square">
+            <a:spAutoFit/>
+          </a:bodyPr>
+          <a:lstStyle/>
+          <a:p>
+            <a:pPr algn="l"/>
+            <a:r>
+              <a:rPr sz="2800" b="1" i="0">
+                <a:solidFill>
+                  <a:srgbClr val="FFFFFF"/>
+                </a:solidFill>
+                <a:latin typeface="Segoe UI"/>
+              </a:rPr>
+              <a:t>Criteria &amp; Key Metric Focus</a:t>
+            </a:r>
+          </a:p>
+        </p:txBody>
+      </p:sp>
+      <p:sp>
+        <p:nvSpPr>
+          <p:cNvPr id="7" name="Rectangle 6"/>
+          <p:cNvSpPr/>
+          <p:nvPr/>
+        </p:nvSpPr>
+        <p:spPr>
+          <a:xfrm>
+            <a:off x="365760" y="1325880"/>
+            <a:ext cx="8412480" cy="14630"/>
+          </a:xfrm>
+          <a:prstGeom prst="rect">
+            <a:avLst/>
+          </a:prstGeom>
+          <a:solidFill>
+            <a:srgbClr val="00C8F0"/>
+          </a:solidFill>
+          <a:ln>
+            <a:noFill/>
+          </a:ln>
+        </p:spPr>
+        <p:style>
+          <a:lnRef idx="1">
+            <a:schemeClr val="accent1"/>
+          </a:lnRef>
+          <a:fillRef idx="3">
+            <a:schemeClr val="accent1"/>
+          </a:fillRef>
+          <a:effectRef idx="2">
+            <a:schemeClr val="accent1"/>
+          </a:effectRef>
+          <a:fontRef idx="minor">
+            <a:schemeClr val="lt1"/>
+          </a:fontRef>
+        </p:style>
+        <p:txBody>
+          <a:bodyPr rtlCol="0" anchor="ctr"/>
+          <a:lstStyle/>
+          <a:p>
+            <a:pPr algn="ctr"/>
+          </a:p>
+        </p:txBody>
+      </p:sp>
+      <p:sp>
+        <p:nvSpPr>
+          <p:cNvPr id="8" name="TextBox 7"/>
+          <p:cNvSpPr txBox="1"/>
+          <p:nvPr/>
+        </p:nvSpPr>
+        <p:spPr>
+          <a:xfrm>
+            <a:off x="347472" y="1417320"/>
+            <a:ext cx="8458200" cy="402336"/>
+          </a:xfrm>
+          <a:prstGeom prst="rect">
+            <a:avLst/>
+          </a:prstGeom>
+          <a:noFill/>
+        </p:spPr>
+        <p:txBody>
+          <a:bodyPr wrap="square">
+            <a:spAutoFit/>
+          </a:bodyPr>
+          <a:lstStyle/>
+          <a:p>
+            <a:pPr algn="l"/>
+            <a:r>
+              <a:rPr sz="1180" b="0" i="1">
+                <a:solidFill>
+                  <a:srgbClr val="B8D0EC"/>
+                </a:solidFill>
+                <a:latin typeface="Segoe UI"/>
+              </a:rPr>
+              <a:t>AEPLO JTAG Accelerator is positioned against the judging matrix with measurable stream value, platform readiness, live execution proof and agentic AI governance.</a:t>
+            </a:r>
+          </a:p>
+        </p:txBody>
+      </p:sp>
+      <p:sp>
+        <p:nvSpPr>
+          <p:cNvPr id="9" name="Rounded Rectangle 8"/>
+          <p:cNvSpPr/>
+          <p:nvPr/>
+        </p:nvSpPr>
+        <p:spPr>
+          <a:xfrm>
+            <a:off x="320040" y="1901952"/>
+            <a:ext cx="8503920" cy="4187952"/>
+          </a:xfrm>
+          <a:prstGeom prst="roundRect">
+            <a:avLst/>
+          </a:prstGeom>
+          <a:solidFill>
+            <a:srgbClr val="0B1F3A"/>
+          </a:solidFill>
+          <a:ln>
+            <a:noFill/>
+          </a:ln>
+        </p:spPr>
+        <p:style>
+          <a:lnRef idx="1">
+            <a:schemeClr val="accent1"/>
+          </a:lnRef>
+          <a:fillRef idx="3">
+            <a:schemeClr val="accent1"/>
+          </a:fillRef>
+          <a:effectRef idx="2">
+            <a:schemeClr val="accent1"/>
+          </a:effectRef>
+          <a:fontRef idx="minor">
+            <a:schemeClr val="lt1"/>
+          </a:fontRef>
+        </p:style>
+        <p:txBody>
+          <a:bodyPr rtlCol="0" anchor="ctr"/>
+          <a:lstStyle/>
+          <a:p>
+            <a:pPr algn="ctr"/>
+          </a:p>
+        </p:txBody>
+      </p:sp>
+      <p:sp>
+        <p:nvSpPr>
+          <p:cNvPr id="10" name="Rectangle 9"/>
+          <p:cNvSpPr/>
+          <p:nvPr/>
+        </p:nvSpPr>
+        <p:spPr>
+          <a:xfrm>
+            <a:off x="320040" y="1901952"/>
+            <a:ext cx="8503920" cy="50292"/>
+          </a:xfrm>
+          <a:prstGeom prst="rect">
+            <a:avLst/>
+          </a:prstGeom>
+          <a:solidFill>
+            <a:srgbClr val="00C8F0"/>
+          </a:solidFill>
+          <a:ln>
+            <a:noFill/>
+          </a:ln>
+        </p:spPr>
+        <p:style>
+          <a:lnRef idx="1">
+            <a:schemeClr val="accent1"/>
+          </a:lnRef>
+          <a:fillRef idx="3">
+            <a:schemeClr val="accent1"/>
+          </a:fillRef>
+          <a:effectRef idx="2">
+            <a:schemeClr val="accent1"/>
+          </a:effectRef>
+          <a:fontRef idx="minor">
+            <a:schemeClr val="lt1"/>
+          </a:fontRef>
+        </p:style>
+        <p:txBody>
+          <a:bodyPr rtlCol="0" anchor="ctr"/>
+          <a:lstStyle/>
+          <a:p>
+            <a:pPr algn="ctr"/>
+          </a:p>
+        </p:txBody>
+      </p:sp>
+      <p:sp>
+        <p:nvSpPr>
+          <p:cNvPr id="11" name="Rectangle 10"/>
+          <p:cNvSpPr/>
+          <p:nvPr/>
+        </p:nvSpPr>
+        <p:spPr>
+          <a:xfrm>
+            <a:off x="320040" y="1901952"/>
+            <a:ext cx="3063240" cy="384048"/>
+          </a:xfrm>
+          <a:prstGeom prst="rect">
+            <a:avLst/>
+          </a:prstGeom>
+          <a:solidFill>
+            <a:srgbClr val="D7F7FF"/>
+          </a:solidFill>
+          <a:ln>
+            <a:noFill/>
+          </a:ln>
+        </p:spPr>
+        <p:style>
+          <a:lnRef idx="1">
+            <a:schemeClr val="accent1"/>
+          </a:lnRef>
+          <a:fillRef idx="3">
+            <a:schemeClr val="accent1"/>
+          </a:fillRef>
+          <a:effectRef idx="2">
+            <a:schemeClr val="accent1"/>
+          </a:effectRef>
+          <a:fontRef idx="minor">
+            <a:schemeClr val="lt1"/>
+          </a:fontRef>
+        </p:style>
+        <p:txBody>
+          <a:bodyPr rtlCol="0" anchor="ctr"/>
+          <a:lstStyle/>
+          <a:p>
+            <a:pPr algn="ctr"/>
+          </a:p>
+        </p:txBody>
+      </p:sp>
+      <p:sp>
+        <p:nvSpPr>
+          <p:cNvPr id="12" name="Rectangle 11"/>
+          <p:cNvSpPr/>
+          <p:nvPr/>
+        </p:nvSpPr>
+        <p:spPr>
+          <a:xfrm>
+            <a:off x="3383280" y="1901952"/>
+            <a:ext cx="5440680" cy="384048"/>
+          </a:xfrm>
+          <a:prstGeom prst="rect">
+            <a:avLst/>
+          </a:prstGeom>
+          <a:solidFill>
+            <a:srgbClr val="D7F7FF"/>
+          </a:solidFill>
+          <a:ln>
+            <a:noFill/>
+          </a:ln>
+        </p:spPr>
+        <p:style>
+          <a:lnRef idx="1">
+            <a:schemeClr val="accent1"/>
+          </a:lnRef>
+          <a:fillRef idx="3">
+            <a:schemeClr val="accent1"/>
+          </a:fillRef>
+          <a:effectRef idx="2">
+            <a:schemeClr val="accent1"/>
+          </a:effectRef>
+          <a:fontRef idx="minor">
+            <a:schemeClr val="lt1"/>
+          </a:fontRef>
+        </p:style>
+        <p:txBody>
+          <a:bodyPr rtlCol="0" anchor="ctr"/>
+          <a:lstStyle/>
+          <a:p>
+            <a:pPr algn="ctr"/>
+          </a:p>
+        </p:txBody>
+      </p:sp>
+      <p:sp>
+        <p:nvSpPr>
+          <p:cNvPr id="13" name="TextBox 12"/>
+          <p:cNvSpPr txBox="1"/>
+          <p:nvPr/>
+        </p:nvSpPr>
+        <p:spPr>
+          <a:xfrm>
+            <a:off x="320040" y="1975104"/>
+            <a:ext cx="3063240" cy="164592"/>
+          </a:xfrm>
+          <a:prstGeom prst="rect">
+            <a:avLst/>
+          </a:prstGeom>
+          <a:noFill/>
+        </p:spPr>
+        <p:txBody>
+          <a:bodyPr wrap="square">
+            <a:spAutoFit/>
+          </a:bodyPr>
+          <a:lstStyle/>
+          <a:p>
+            <a:pPr algn="ctr"/>
+            <a:r>
+              <a:rPr sz="1050" b="1" i="0">
+                <a:solidFill>
+                  <a:srgbClr val="05142E"/>
+                </a:solidFill>
+                <a:latin typeface="Segoe UI"/>
+              </a:rPr>
+              <a:t>CRITERIA</a:t>
+            </a:r>
+          </a:p>
+        </p:txBody>
+      </p:sp>
+      <p:sp>
+        <p:nvSpPr>
+          <p:cNvPr id="14" name="TextBox 13"/>
+          <p:cNvSpPr txBox="1"/>
+          <p:nvPr/>
+        </p:nvSpPr>
+        <p:spPr>
+          <a:xfrm>
+            <a:off x="3383280" y="1975104"/>
+            <a:ext cx="5440680" cy="164592"/>
+          </a:xfrm>
+          <a:prstGeom prst="rect">
+            <a:avLst/>
+          </a:prstGeom>
+          <a:noFill/>
+        </p:spPr>
+        <p:txBody>
+          <a:bodyPr wrap="square">
+            <a:spAutoFit/>
+          </a:bodyPr>
+          <a:lstStyle/>
+          <a:p>
+            <a:pPr algn="ctr"/>
+            <a:r>
+              <a:rPr sz="1050" b="1" i="0">
+                <a:solidFill>
+                  <a:srgbClr val="05142E"/>
+                </a:solidFill>
+                <a:latin typeface="Segoe UI"/>
+              </a:rPr>
+              <a:t>KEY METRIC FOCUS</a:t>
+            </a:r>
+          </a:p>
+        </p:txBody>
+      </p:sp>
+      <p:sp>
+        <p:nvSpPr>
+          <p:cNvPr id="15" name="Rectangle 14"/>
+          <p:cNvSpPr/>
+          <p:nvPr/>
+        </p:nvSpPr>
+        <p:spPr>
+          <a:xfrm>
+            <a:off x="320040" y="2286000"/>
+            <a:ext cx="3063240" cy="658368"/>
+          </a:xfrm>
+          <a:prstGeom prst="rect">
+            <a:avLst/>
+          </a:prstGeom>
+          <a:solidFill>
+            <a:srgbClr val="0F2845"/>
+          </a:solidFill>
+          <a:ln>
+            <a:noFill/>
+          </a:ln>
+        </p:spPr>
+        <p:style>
+          <a:lnRef idx="1">
+            <a:schemeClr val="accent1"/>
+          </a:lnRef>
+          <a:fillRef idx="3">
+            <a:schemeClr val="accent1"/>
+          </a:fillRef>
+          <a:effectRef idx="2">
+            <a:schemeClr val="accent1"/>
+          </a:effectRef>
+          <a:fontRef idx="minor">
+            <a:schemeClr val="lt1"/>
+          </a:fontRef>
+        </p:style>
+        <p:txBody>
+          <a:bodyPr rtlCol="0" anchor="ctr"/>
+          <a:lstStyle/>
+          <a:p>
+            <a:pPr algn="ctr"/>
+          </a:p>
+        </p:txBody>
+      </p:sp>
+      <p:sp>
+        <p:nvSpPr>
+          <p:cNvPr id="16" name="Rectangle 15"/>
+          <p:cNvSpPr/>
+          <p:nvPr/>
+        </p:nvSpPr>
+        <p:spPr>
+          <a:xfrm>
+            <a:off x="3383280" y="2286000"/>
+            <a:ext cx="5440680" cy="658368"/>
+          </a:xfrm>
+          <a:prstGeom prst="rect">
+            <a:avLst/>
+          </a:prstGeom>
+          <a:solidFill>
+            <a:srgbClr val="0F2845"/>
+          </a:solidFill>
+          <a:ln>
+            <a:noFill/>
+          </a:ln>
+        </p:spPr>
+        <p:style>
+          <a:lnRef idx="1">
+            <a:schemeClr val="accent1"/>
+          </a:lnRef>
+          <a:fillRef idx="3">
+            <a:schemeClr val="accent1"/>
+          </a:fillRef>
+          <a:effectRef idx="2">
+            <a:schemeClr val="accent1"/>
+          </a:effectRef>
+          <a:fontRef idx="minor">
+            <a:schemeClr val="lt1"/>
+          </a:fontRef>
+        </p:style>
+        <p:txBody>
+          <a:bodyPr rtlCol="0" anchor="ctr"/>
+          <a:lstStyle/>
+          <a:p>
+            <a:pPr algn="ctr"/>
+          </a:p>
+        </p:txBody>
+      </p:sp>
+      <p:sp>
+        <p:nvSpPr>
+          <p:cNvPr id="17" name="Rectangle 16"/>
+          <p:cNvSpPr/>
+          <p:nvPr/>
+        </p:nvSpPr>
+        <p:spPr>
+          <a:xfrm>
+            <a:off x="320040" y="2286000"/>
+            <a:ext cx="50292" cy="658368"/>
+          </a:xfrm>
+          <a:prstGeom prst="rect">
+            <a:avLst/>
+          </a:prstGeom>
+          <a:solidFill>
+            <a:srgbClr val="00D48A"/>
+          </a:solidFill>
+          <a:ln>
+            <a:noFill/>
+          </a:ln>
+        </p:spPr>
+        <p:style>
+          <a:lnRef idx="1">
+            <a:schemeClr val="accent1"/>
+          </a:lnRef>
+          <a:fillRef idx="3">
+            <a:schemeClr val="accent1"/>
+          </a:fillRef>
+          <a:effectRef idx="2">
+            <a:schemeClr val="accent1"/>
+          </a:effectRef>
+          <a:fontRef idx="minor">
+            <a:schemeClr val="lt1"/>
+          </a:fontRef>
+        </p:style>
+        <p:txBody>
+          <a:bodyPr rtlCol="0" anchor="ctr"/>
+          <a:lstStyle/>
+          <a:p>
+            <a:pPr algn="ctr"/>
+          </a:p>
+        </p:txBody>
+      </p:sp>
+      <p:sp>
+        <p:nvSpPr>
+          <p:cNvPr id="18" name="Rectangle 17"/>
+          <p:cNvSpPr/>
+          <p:nvPr/>
+        </p:nvSpPr>
+        <p:spPr>
+          <a:xfrm>
+            <a:off x="3383280" y="2286000"/>
+            <a:ext cx="20116" cy="658368"/>
+          </a:xfrm>
+          <a:prstGeom prst="rect">
+            <a:avLst/>
+          </a:prstGeom>
+          <a:solidFill>
+            <a:srgbClr val="204A70"/>
+          </a:solidFill>
+          <a:ln>
+            <a:noFill/>
+          </a:ln>
+        </p:spPr>
+        <p:style>
+          <a:lnRef idx="1">
+            <a:schemeClr val="accent1"/>
+          </a:lnRef>
+          <a:fillRef idx="3">
+            <a:schemeClr val="accent1"/>
+          </a:fillRef>
+          <a:effectRef idx="2">
+            <a:schemeClr val="accent1"/>
+          </a:effectRef>
+          <a:fontRef idx="minor">
+            <a:schemeClr val="lt1"/>
+          </a:fontRef>
+        </p:style>
+        <p:txBody>
+          <a:bodyPr rtlCol="0" anchor="ctr"/>
+          <a:lstStyle/>
+          <a:p>
+            <a:pPr algn="ctr"/>
+          </a:p>
+        </p:txBody>
+      </p:sp>
+      <p:sp>
+        <p:nvSpPr>
+          <p:cNvPr id="19" name="Rectangle 18"/>
+          <p:cNvSpPr/>
+          <p:nvPr/>
+        </p:nvSpPr>
+        <p:spPr>
+          <a:xfrm>
+            <a:off x="320040" y="2286000"/>
+            <a:ext cx="8503920" cy="10972"/>
+          </a:xfrm>
+          <a:prstGeom prst="rect">
+            <a:avLst/>
+          </a:prstGeom>
+          <a:solidFill>
+            <a:srgbClr val="204A70"/>
+          </a:solidFill>
+          <a:ln>
+            <a:noFill/>
+          </a:ln>
+        </p:spPr>
+        <p:style>
+          <a:lnRef idx="1">
+            <a:schemeClr val="accent1"/>
+          </a:lnRef>
+          <a:fillRef idx="3">
+            <a:schemeClr val="accent1"/>
+          </a:fillRef>
+          <a:effectRef idx="2">
+            <a:schemeClr val="accent1"/>
+          </a:effectRef>
+          <a:fontRef idx="minor">
+            <a:schemeClr val="lt1"/>
+          </a:fontRef>
+        </p:style>
+        <p:txBody>
+          <a:bodyPr rtlCol="0" anchor="ctr"/>
+          <a:lstStyle/>
+          <a:p>
+            <a:pPr algn="ctr"/>
+          </a:p>
+        </p:txBody>
+      </p:sp>
+      <p:sp>
+        <p:nvSpPr>
+          <p:cNvPr id="20" name="TextBox 19"/>
+          <p:cNvSpPr txBox="1"/>
+          <p:nvPr/>
+        </p:nvSpPr>
+        <p:spPr>
+          <a:xfrm>
+            <a:off x="484632" y="2395728"/>
+            <a:ext cx="2743200" cy="493776"/>
+          </a:xfrm>
+          <a:prstGeom prst="rect">
+            <a:avLst/>
+          </a:prstGeom>
+          <a:noFill/>
+        </p:spPr>
+        <p:txBody>
+          <a:bodyPr wrap="square">
+            <a:spAutoFit/>
+          </a:bodyPr>
+          <a:lstStyle/>
+          <a:p>
+            <a:pPr algn="l"/>
+            <a:r>
+              <a:rPr sz="1100" b="1" i="0">
+                <a:solidFill>
+                  <a:srgbClr val="FFFFFF"/>
+                </a:solidFill>
+                <a:latin typeface="Segoe UI"/>
+              </a:rPr>
+              <a:t>Stream Value</a:t>
+            </a:r>
+          </a:p>
+        </p:txBody>
+      </p:sp>
+      <p:sp>
+        <p:nvSpPr>
+          <p:cNvPr id="21" name="TextBox 20"/>
+          <p:cNvSpPr txBox="1"/>
+          <p:nvPr/>
+        </p:nvSpPr>
+        <p:spPr>
+          <a:xfrm>
+            <a:off x="3584448" y="2395728"/>
+            <a:ext cx="5056632" cy="493776"/>
+          </a:xfrm>
+          <a:prstGeom prst="rect">
+            <a:avLst/>
+          </a:prstGeom>
+          <a:noFill/>
+        </p:spPr>
+        <p:txBody>
+          <a:bodyPr wrap="square">
+            <a:spAutoFit/>
+          </a:bodyPr>
+          <a:lstStyle/>
+          <a:p>
+            <a:pPr algn="l"/>
+            <a:r>
+              <a:rPr sz="940" b="0" i="0">
+                <a:solidFill>
+                  <a:srgbClr val="B8D0EC"/>
+                </a:solidFill>
+                <a:latin typeface="Segoe UI"/>
+              </a:rPr>
+              <a:t>- PDLC engineering lead-time drop
+- Defect rate reduction
+- Projected productivity savings 2026 H2 and 2027</a:t>
+            </a:r>
+          </a:p>
+        </p:txBody>
+      </p:sp>
+      <p:sp>
+        <p:nvSpPr>
+          <p:cNvPr id="22" name="Rectangle 21"/>
+          <p:cNvSpPr/>
+          <p:nvPr/>
+        </p:nvSpPr>
+        <p:spPr>
+          <a:xfrm>
+            <a:off x="320040" y="2944368"/>
+            <a:ext cx="3063240" cy="475488"/>
+          </a:xfrm>
+          <a:prstGeom prst="rect">
+            <a:avLst/>
+          </a:prstGeom>
+          <a:solidFill>
+            <a:srgbClr val="0B233F"/>
+          </a:solidFill>
+          <a:ln>
+            <a:noFill/>
+          </a:ln>
+        </p:spPr>
+        <p:style>
+          <a:lnRef idx="1">
+            <a:schemeClr val="accent1"/>
+          </a:lnRef>
+          <a:fillRef idx="3">
+            <a:schemeClr val="accent1"/>
+          </a:fillRef>
+          <a:effectRef idx="2">
+            <a:schemeClr val="accent1"/>
+          </a:effectRef>
+          <a:fontRef idx="minor">
+            <a:schemeClr val="lt1"/>
+          </a:fontRef>
+        </p:style>
+        <p:txBody>
+          <a:bodyPr rtlCol="0" anchor="ctr"/>
+          <a:lstStyle/>
+          <a:p>
+            <a:pPr algn="ctr"/>
+          </a:p>
+        </p:txBody>
+      </p:sp>
+      <p:sp>
+        <p:nvSpPr>
+          <p:cNvPr id="23" name="Rectangle 22"/>
+          <p:cNvSpPr/>
+          <p:nvPr/>
+        </p:nvSpPr>
+        <p:spPr>
+          <a:xfrm>
+            <a:off x="3383280" y="2944368"/>
+            <a:ext cx="5440680" cy="475488"/>
+          </a:xfrm>
+          <a:prstGeom prst="rect">
+            <a:avLst/>
+          </a:prstGeom>
+          <a:solidFill>
+            <a:srgbClr val="0B233F"/>
+          </a:solidFill>
+          <a:ln>
+            <a:noFill/>
+          </a:ln>
+        </p:spPr>
+        <p:style>
+          <a:lnRef idx="1">
+            <a:schemeClr val="accent1"/>
+          </a:lnRef>
+          <a:fillRef idx="3">
+            <a:schemeClr val="accent1"/>
+          </a:fillRef>
+          <a:effectRef idx="2">
+            <a:schemeClr val="accent1"/>
+          </a:effectRef>
+          <a:fontRef idx="minor">
+            <a:schemeClr val="lt1"/>
+          </a:fontRef>
+        </p:style>
+        <p:txBody>
+          <a:bodyPr rtlCol="0" anchor="ctr"/>
+          <a:lstStyle/>
+          <a:p>
+            <a:pPr algn="ctr"/>
+          </a:p>
+        </p:txBody>
+      </p:sp>
+      <p:sp>
+        <p:nvSpPr>
+          <p:cNvPr id="24" name="Rectangle 23"/>
+          <p:cNvSpPr/>
+          <p:nvPr/>
+        </p:nvSpPr>
+        <p:spPr>
+          <a:xfrm>
+            <a:off x="320040" y="2944368"/>
+            <a:ext cx="50292" cy="475488"/>
+          </a:xfrm>
+          <a:prstGeom prst="rect">
+            <a:avLst/>
+          </a:prstGeom>
+          <a:solidFill>
+            <a:srgbClr val="0072C6"/>
+          </a:solidFill>
+          <a:ln>
+            <a:noFill/>
+          </a:ln>
+        </p:spPr>
+        <p:style>
+          <a:lnRef idx="1">
+            <a:schemeClr val="accent1"/>
+          </a:lnRef>
+          <a:fillRef idx="3">
+            <a:schemeClr val="accent1"/>
+          </a:fillRef>
+          <a:effectRef idx="2">
+            <a:schemeClr val="accent1"/>
+          </a:effectRef>
+          <a:fontRef idx="minor">
+            <a:schemeClr val="lt1"/>
+          </a:fontRef>
+        </p:style>
+        <p:txBody>
+          <a:bodyPr rtlCol="0" anchor="ctr"/>
+          <a:lstStyle/>
+          <a:p>
+            <a:pPr algn="ctr"/>
+          </a:p>
+        </p:txBody>
+      </p:sp>
+      <p:sp>
+        <p:nvSpPr>
+          <p:cNvPr id="25" name="Rectangle 24"/>
+          <p:cNvSpPr/>
+          <p:nvPr/>
+        </p:nvSpPr>
+        <p:spPr>
+          <a:xfrm>
+            <a:off x="3383280" y="2944368"/>
+            <a:ext cx="20116" cy="475488"/>
+          </a:xfrm>
+          <a:prstGeom prst="rect">
+            <a:avLst/>
+          </a:prstGeom>
+          <a:solidFill>
+            <a:srgbClr val="204A70"/>
+          </a:solidFill>
+          <a:ln>
+            <a:noFill/>
+          </a:ln>
+        </p:spPr>
+        <p:style>
+          <a:lnRef idx="1">
+            <a:schemeClr val="accent1"/>
+          </a:lnRef>
+          <a:fillRef idx="3">
+            <a:schemeClr val="accent1"/>
+          </a:fillRef>
+          <a:effectRef idx="2">
+            <a:schemeClr val="accent1"/>
+          </a:effectRef>
+          <a:fontRef idx="minor">
+            <a:schemeClr val="lt1"/>
+          </a:fontRef>
+        </p:style>
+        <p:txBody>
+          <a:bodyPr rtlCol="0" anchor="ctr"/>
+          <a:lstStyle/>
+          <a:p>
+            <a:pPr algn="ctr"/>
+          </a:p>
+        </p:txBody>
+      </p:sp>
+      <p:sp>
+        <p:nvSpPr>
+          <p:cNvPr id="26" name="Rectangle 25"/>
+          <p:cNvSpPr/>
+          <p:nvPr/>
+        </p:nvSpPr>
+        <p:spPr>
+          <a:xfrm>
+            <a:off x="320040" y="2944368"/>
+            <a:ext cx="8503920" cy="10972"/>
+          </a:xfrm>
+          <a:prstGeom prst="rect">
+            <a:avLst/>
+          </a:prstGeom>
+          <a:solidFill>
+            <a:srgbClr val="204A70"/>
+          </a:solidFill>
+          <a:ln>
+            <a:noFill/>
+          </a:ln>
+        </p:spPr>
+        <p:style>
+          <a:lnRef idx="1">
+            <a:schemeClr val="accent1"/>
+          </a:lnRef>
+          <a:fillRef idx="3">
+            <a:schemeClr val="accent1"/>
+          </a:fillRef>
+          <a:effectRef idx="2">
+            <a:schemeClr val="accent1"/>
+          </a:effectRef>
+          <a:fontRef idx="minor">
+            <a:schemeClr val="lt1"/>
+          </a:fontRef>
+        </p:style>
+        <p:txBody>
+          <a:bodyPr rtlCol="0" anchor="ctr"/>
+          <a:lstStyle/>
+          <a:p>
+            <a:pPr algn="ctr"/>
+          </a:p>
+        </p:txBody>
+      </p:sp>
+      <p:sp>
+        <p:nvSpPr>
+          <p:cNvPr id="27" name="TextBox 26"/>
+          <p:cNvSpPr txBox="1"/>
+          <p:nvPr/>
+        </p:nvSpPr>
+        <p:spPr>
+          <a:xfrm>
+            <a:off x="484632" y="3054096"/>
+            <a:ext cx="2743200" cy="310896"/>
+          </a:xfrm>
+          <a:prstGeom prst="rect">
+            <a:avLst/>
+          </a:prstGeom>
+          <a:noFill/>
+        </p:spPr>
+        <p:txBody>
+          <a:bodyPr wrap="square">
+            <a:spAutoFit/>
+          </a:bodyPr>
+          <a:lstStyle/>
+          <a:p>
+            <a:pPr algn="l"/>
+            <a:r>
+              <a:rPr sz="1100" b="1" i="0">
+                <a:solidFill>
+                  <a:srgbClr val="FFFFFF"/>
+                </a:solidFill>
+                <a:latin typeface="Segoe UI"/>
+              </a:rPr>
+              <a:t>Platformization</a:t>
+            </a:r>
+          </a:p>
+        </p:txBody>
+      </p:sp>
+      <p:sp>
+        <p:nvSpPr>
+          <p:cNvPr id="28" name="TextBox 27"/>
+          <p:cNvSpPr txBox="1"/>
+          <p:nvPr/>
+        </p:nvSpPr>
+        <p:spPr>
+          <a:xfrm>
+            <a:off x="3584448" y="3054096"/>
+            <a:ext cx="5056632" cy="310896"/>
+          </a:xfrm>
+          <a:prstGeom prst="rect">
+            <a:avLst/>
+          </a:prstGeom>
+          <a:noFill/>
+        </p:spPr>
+        <p:txBody>
+          <a:bodyPr wrap="square">
+            <a:spAutoFit/>
+          </a:bodyPr>
+          <a:lstStyle/>
+          <a:p>
+            <a:pPr algn="l"/>
+            <a:r>
+              <a:rPr sz="940" b="0" i="0">
+                <a:solidFill>
+                  <a:srgbClr val="B8D0EC"/>
+                </a:solidFill>
+                <a:latin typeface="Segoe UI"/>
+              </a:rPr>
+              <a:t>- BA-org hosting readiness %</a:t>
+            </a:r>
+          </a:p>
+        </p:txBody>
+      </p:sp>
+      <p:sp>
+        <p:nvSpPr>
+          <p:cNvPr id="29" name="Rectangle 28"/>
+          <p:cNvSpPr/>
+          <p:nvPr/>
+        </p:nvSpPr>
+        <p:spPr>
+          <a:xfrm>
+            <a:off x="320040" y="3419856"/>
+            <a:ext cx="3063240" cy="658368"/>
+          </a:xfrm>
+          <a:prstGeom prst="rect">
+            <a:avLst/>
+          </a:prstGeom>
+          <a:solidFill>
+            <a:srgbClr val="0F2845"/>
+          </a:solidFill>
+          <a:ln>
+            <a:noFill/>
+          </a:ln>
+        </p:spPr>
+        <p:style>
+          <a:lnRef idx="1">
+            <a:schemeClr val="accent1"/>
+          </a:lnRef>
+          <a:fillRef idx="3">
+            <a:schemeClr val="accent1"/>
+          </a:fillRef>
+          <a:effectRef idx="2">
+            <a:schemeClr val="accent1"/>
+          </a:effectRef>
+          <a:fontRef idx="minor">
+            <a:schemeClr val="lt1"/>
+          </a:fontRef>
+        </p:style>
+        <p:txBody>
+          <a:bodyPr rtlCol="0" anchor="ctr"/>
+          <a:lstStyle/>
+          <a:p>
+            <a:pPr algn="ctr"/>
+          </a:p>
+        </p:txBody>
+      </p:sp>
+      <p:sp>
+        <p:nvSpPr>
+          <p:cNvPr id="30" name="Rectangle 29"/>
+          <p:cNvSpPr/>
+          <p:nvPr/>
+        </p:nvSpPr>
+        <p:spPr>
+          <a:xfrm>
+            <a:off x="3383280" y="3419856"/>
+            <a:ext cx="5440680" cy="658368"/>
+          </a:xfrm>
+          <a:prstGeom prst="rect">
+            <a:avLst/>
+          </a:prstGeom>
+          <a:solidFill>
+            <a:srgbClr val="0F2845"/>
+          </a:solidFill>
+          <a:ln>
+            <a:noFill/>
+          </a:ln>
+        </p:spPr>
+        <p:style>
+          <a:lnRef idx="1">
+            <a:schemeClr val="accent1"/>
+          </a:lnRef>
+          <a:fillRef idx="3">
+            <a:schemeClr val="accent1"/>
+          </a:fillRef>
+          <a:effectRef idx="2">
+            <a:schemeClr val="accent1"/>
+          </a:effectRef>
+          <a:fontRef idx="minor">
+            <a:schemeClr val="lt1"/>
+          </a:fontRef>
+        </p:style>
+        <p:txBody>
+          <a:bodyPr rtlCol="0" anchor="ctr"/>
+          <a:lstStyle/>
+          <a:p>
+            <a:pPr algn="ctr"/>
+          </a:p>
+        </p:txBody>
+      </p:sp>
+      <p:sp>
+        <p:nvSpPr>
+          <p:cNvPr id="31" name="Rectangle 30"/>
+          <p:cNvSpPr/>
+          <p:nvPr/>
+        </p:nvSpPr>
+        <p:spPr>
+          <a:xfrm>
+            <a:off x="320040" y="3419856"/>
+            <a:ext cx="50292" cy="658368"/>
+          </a:xfrm>
+          <a:prstGeom prst="rect">
+            <a:avLst/>
+          </a:prstGeom>
+          <a:solidFill>
+            <a:srgbClr val="FF8C00"/>
+          </a:solidFill>
+          <a:ln>
+            <a:noFill/>
+          </a:ln>
+        </p:spPr>
+        <p:style>
+          <a:lnRef idx="1">
+            <a:schemeClr val="accent1"/>
+          </a:lnRef>
+          <a:fillRef idx="3">
+            <a:schemeClr val="accent1"/>
+          </a:fillRef>
+          <a:effectRef idx="2">
+            <a:schemeClr val="accent1"/>
+          </a:effectRef>
+          <a:fontRef idx="minor">
+            <a:schemeClr val="lt1"/>
+          </a:fontRef>
+        </p:style>
+        <p:txBody>
+          <a:bodyPr rtlCol="0" anchor="ctr"/>
+          <a:lstStyle/>
+          <a:p>
+            <a:pPr algn="ctr"/>
+          </a:p>
+        </p:txBody>
+      </p:sp>
+      <p:sp>
+        <p:nvSpPr>
+          <p:cNvPr id="32" name="Rectangle 31"/>
+          <p:cNvSpPr/>
+          <p:nvPr/>
+        </p:nvSpPr>
+        <p:spPr>
+          <a:xfrm>
+            <a:off x="3383280" y="3419856"/>
+            <a:ext cx="20116" cy="658368"/>
+          </a:xfrm>
+          <a:prstGeom prst="rect">
+            <a:avLst/>
+          </a:prstGeom>
+          <a:solidFill>
+            <a:srgbClr val="204A70"/>
+          </a:solidFill>
+          <a:ln>
+            <a:noFill/>
+          </a:ln>
+        </p:spPr>
+        <p:style>
+          <a:lnRef idx="1">
+            <a:schemeClr val="accent1"/>
+          </a:lnRef>
+          <a:fillRef idx="3">
+            <a:schemeClr val="accent1"/>
+          </a:fillRef>
+          <a:effectRef idx="2">
+            <a:schemeClr val="accent1"/>
+          </a:effectRef>
+          <a:fontRef idx="minor">
+            <a:schemeClr val="lt1"/>
+          </a:fontRef>
+        </p:style>
+        <p:txBody>
+          <a:bodyPr rtlCol="0" anchor="ctr"/>
+          <a:lstStyle/>
+          <a:p>
+            <a:pPr algn="ctr"/>
+          </a:p>
+        </p:txBody>
+      </p:sp>
+      <p:sp>
+        <p:nvSpPr>
+          <p:cNvPr id="33" name="Rectangle 32"/>
+          <p:cNvSpPr/>
+          <p:nvPr/>
+        </p:nvSpPr>
+        <p:spPr>
+          <a:xfrm>
+            <a:off x="320040" y="3419856"/>
+            <a:ext cx="8503920" cy="10972"/>
+          </a:xfrm>
+          <a:prstGeom prst="rect">
+            <a:avLst/>
+          </a:prstGeom>
+          <a:solidFill>
+            <a:srgbClr val="204A70"/>
+          </a:solidFill>
+          <a:ln>
+            <a:noFill/>
+          </a:ln>
+        </p:spPr>
+        <p:style>
+          <a:lnRef idx="1">
+            <a:schemeClr val="accent1"/>
+          </a:lnRef>
+          <a:fillRef idx="3">
+            <a:schemeClr val="accent1"/>
+          </a:fillRef>
+          <a:effectRef idx="2">
+            <a:schemeClr val="accent1"/>
+          </a:effectRef>
+          <a:fontRef idx="minor">
+            <a:schemeClr val="lt1"/>
+          </a:fontRef>
+        </p:style>
+        <p:txBody>
+          <a:bodyPr rtlCol="0" anchor="ctr"/>
+          <a:lstStyle/>
+          <a:p>
+            <a:pPr algn="ctr"/>
+          </a:p>
+        </p:txBody>
+      </p:sp>
+      <p:sp>
+        <p:nvSpPr>
+          <p:cNvPr id="34" name="TextBox 33"/>
+          <p:cNvSpPr txBox="1"/>
+          <p:nvPr/>
+        </p:nvSpPr>
+        <p:spPr>
+          <a:xfrm>
+            <a:off x="484632" y="3529584"/>
+            <a:ext cx="2743200" cy="493776"/>
+          </a:xfrm>
+          <a:prstGeom prst="rect">
+            <a:avLst/>
+          </a:prstGeom>
+          <a:noFill/>
+        </p:spPr>
+        <p:txBody>
+          <a:bodyPr wrap="square">
+            <a:spAutoFit/>
+          </a:bodyPr>
+          <a:lstStyle/>
+          <a:p>
+            <a:pPr algn="l"/>
+            <a:r>
+              <a:rPr sz="1100" b="1" i="0">
+                <a:solidFill>
+                  <a:srgbClr val="FFFFFF"/>
+                </a:solidFill>
+                <a:latin typeface="Segoe UI"/>
+              </a:rPr>
+              <a:t>Live Execution</a:t>
+            </a:r>
+          </a:p>
+        </p:txBody>
+      </p:sp>
+      <p:sp>
+        <p:nvSpPr>
+          <p:cNvPr id="35" name="TextBox 34"/>
+          <p:cNvSpPr txBox="1"/>
+          <p:nvPr/>
+        </p:nvSpPr>
+        <p:spPr>
+          <a:xfrm>
+            <a:off x="3584448" y="3529584"/>
+            <a:ext cx="5056632" cy="493776"/>
+          </a:xfrm>
+          <a:prstGeom prst="rect">
+            <a:avLst/>
+          </a:prstGeom>
+          <a:noFill/>
+        </p:spPr>
+        <p:txBody>
+          <a:bodyPr wrap="square">
+            <a:spAutoFit/>
+          </a:bodyPr>
+          <a:lstStyle/>
+          <a:p>
+            <a:pPr algn="l"/>
+            <a:r>
+              <a:rPr sz="940" b="0" i="0">
+                <a:solidFill>
+                  <a:srgbClr val="B8D0EC"/>
+                </a:solidFill>
+                <a:latin typeface="Segoe UI"/>
+              </a:rPr>
+              <a:t>A fully functional, resilient working prototype and impact in ongoing active projects</a:t>
+            </a:r>
+          </a:p>
+        </p:txBody>
+      </p:sp>
+      <p:sp>
+        <p:nvSpPr>
+          <p:cNvPr id="36" name="Rectangle 35"/>
+          <p:cNvSpPr/>
+          <p:nvPr/>
+        </p:nvSpPr>
+        <p:spPr>
+          <a:xfrm>
+            <a:off x="320040" y="4078224"/>
+            <a:ext cx="3063240" cy="932688"/>
+          </a:xfrm>
+          <a:prstGeom prst="rect">
+            <a:avLst/>
+          </a:prstGeom>
+          <a:solidFill>
+            <a:srgbClr val="0B233F"/>
+          </a:solidFill>
+          <a:ln>
+            <a:noFill/>
+          </a:ln>
+        </p:spPr>
+        <p:style>
+          <a:lnRef idx="1">
+            <a:schemeClr val="accent1"/>
+          </a:lnRef>
+          <a:fillRef idx="3">
+            <a:schemeClr val="accent1"/>
+          </a:fillRef>
+          <a:effectRef idx="2">
+            <a:schemeClr val="accent1"/>
+          </a:effectRef>
+          <a:fontRef idx="minor">
+            <a:schemeClr val="lt1"/>
+          </a:fontRef>
+        </p:style>
+        <p:txBody>
+          <a:bodyPr rtlCol="0" anchor="ctr"/>
+          <a:lstStyle/>
+          <a:p>
+            <a:pPr algn="ctr"/>
+          </a:p>
+        </p:txBody>
+      </p:sp>
+      <p:sp>
+        <p:nvSpPr>
+          <p:cNvPr id="37" name="Rectangle 36"/>
+          <p:cNvSpPr/>
+          <p:nvPr/>
+        </p:nvSpPr>
+        <p:spPr>
+          <a:xfrm>
+            <a:off x="3383280" y="4078224"/>
+            <a:ext cx="5440680" cy="932688"/>
+          </a:xfrm>
+          <a:prstGeom prst="rect">
+            <a:avLst/>
+          </a:prstGeom>
+          <a:solidFill>
+            <a:srgbClr val="0B233F"/>
+          </a:solidFill>
+          <a:ln>
+            <a:noFill/>
+          </a:ln>
+        </p:spPr>
+        <p:style>
+          <a:lnRef idx="1">
+            <a:schemeClr val="accent1"/>
+          </a:lnRef>
+          <a:fillRef idx="3">
+            <a:schemeClr val="accent1"/>
+          </a:fillRef>
+          <a:effectRef idx="2">
+            <a:schemeClr val="accent1"/>
+          </a:effectRef>
+          <a:fontRef idx="minor">
+            <a:schemeClr val="lt1"/>
+          </a:fontRef>
+        </p:style>
+        <p:txBody>
+          <a:bodyPr rtlCol="0" anchor="ctr"/>
+          <a:lstStyle/>
+          <a:p>
+            <a:pPr algn="ctr"/>
+          </a:p>
+        </p:txBody>
+      </p:sp>
+      <p:sp>
+        <p:nvSpPr>
+          <p:cNvPr id="38" name="Rectangle 37"/>
+          <p:cNvSpPr/>
+          <p:nvPr/>
+        </p:nvSpPr>
+        <p:spPr>
+          <a:xfrm>
+            <a:off x="320040" y="4078224"/>
+            <a:ext cx="50292" cy="932688"/>
+          </a:xfrm>
+          <a:prstGeom prst="rect">
+            <a:avLst/>
+          </a:prstGeom>
+          <a:solidFill>
+            <a:srgbClr val="8B5CF6"/>
+          </a:solidFill>
+          <a:ln>
+            <a:noFill/>
+          </a:ln>
+        </p:spPr>
+        <p:style>
+          <a:lnRef idx="1">
+            <a:schemeClr val="accent1"/>
+          </a:lnRef>
+          <a:fillRef idx="3">
+            <a:schemeClr val="accent1"/>
+          </a:fillRef>
+          <a:effectRef idx="2">
+            <a:schemeClr val="accent1"/>
+          </a:effectRef>
+          <a:fontRef idx="minor">
+            <a:schemeClr val="lt1"/>
+          </a:fontRef>
+        </p:style>
+        <p:txBody>
+          <a:bodyPr rtlCol="0" anchor="ctr"/>
+          <a:lstStyle/>
+          <a:p>
+            <a:pPr algn="ctr"/>
+          </a:p>
+        </p:txBody>
+      </p:sp>
+      <p:sp>
+        <p:nvSpPr>
+          <p:cNvPr id="39" name="Rectangle 38"/>
+          <p:cNvSpPr/>
+          <p:nvPr/>
+        </p:nvSpPr>
+        <p:spPr>
+          <a:xfrm>
+            <a:off x="3383280" y="4078224"/>
+            <a:ext cx="20116" cy="932688"/>
+          </a:xfrm>
+          <a:prstGeom prst="rect">
+            <a:avLst/>
+          </a:prstGeom>
+          <a:solidFill>
+            <a:srgbClr val="204A70"/>
+          </a:solidFill>
+          <a:ln>
+            <a:noFill/>
+          </a:ln>
+        </p:spPr>
+        <p:style>
+          <a:lnRef idx="1">
+            <a:schemeClr val="accent1"/>
+          </a:lnRef>
+          <a:fillRef idx="3">
+            <a:schemeClr val="accent1"/>
+          </a:fillRef>
+          <a:effectRef idx="2">
+            <a:schemeClr val="accent1"/>
+          </a:effectRef>
+          <a:fontRef idx="minor">
+            <a:schemeClr val="lt1"/>
+          </a:fontRef>
+        </p:style>
+        <p:txBody>
+          <a:bodyPr rtlCol="0" anchor="ctr"/>
+          <a:lstStyle/>
+          <a:p>
+            <a:pPr algn="ctr"/>
+          </a:p>
+        </p:txBody>
+      </p:sp>
+      <p:sp>
+        <p:nvSpPr>
+          <p:cNvPr id="40" name="Rectangle 39"/>
+          <p:cNvSpPr/>
+          <p:nvPr/>
+        </p:nvSpPr>
+        <p:spPr>
+          <a:xfrm>
+            <a:off x="320040" y="4078224"/>
+            <a:ext cx="8503920" cy="10972"/>
+          </a:xfrm>
+          <a:prstGeom prst="rect">
+            <a:avLst/>
+          </a:prstGeom>
+          <a:solidFill>
+            <a:srgbClr val="204A70"/>
+          </a:solidFill>
+          <a:ln>
+            <a:noFill/>
+          </a:ln>
+        </p:spPr>
+        <p:style>
+          <a:lnRef idx="1">
+            <a:schemeClr val="accent1"/>
+          </a:lnRef>
+          <a:fillRef idx="3">
+            <a:schemeClr val="accent1"/>
+          </a:fillRef>
+          <a:effectRef idx="2">
+            <a:schemeClr val="accent1"/>
+          </a:effectRef>
+          <a:fontRef idx="minor">
+            <a:schemeClr val="lt1"/>
+          </a:fontRef>
+        </p:style>
+        <p:txBody>
+          <a:bodyPr rtlCol="0" anchor="ctr"/>
+          <a:lstStyle/>
+          <a:p>
+            <a:pPr algn="ctr"/>
+          </a:p>
+        </p:txBody>
+      </p:sp>
+      <p:sp>
+        <p:nvSpPr>
+          <p:cNvPr id="41" name="TextBox 40"/>
+          <p:cNvSpPr txBox="1"/>
+          <p:nvPr/>
+        </p:nvSpPr>
+        <p:spPr>
+          <a:xfrm>
+            <a:off x="484632" y="4187952"/>
+            <a:ext cx="2743200" cy="768096"/>
+          </a:xfrm>
+          <a:prstGeom prst="rect">
+            <a:avLst/>
+          </a:prstGeom>
+          <a:noFill/>
+        </p:spPr>
+        <p:txBody>
+          <a:bodyPr wrap="square">
+            <a:spAutoFit/>
+          </a:bodyPr>
+          <a:lstStyle/>
+          <a:p>
+            <a:pPr algn="l"/>
+            <a:r>
+              <a:rPr sz="830" b="1" i="0">
+                <a:solidFill>
+                  <a:srgbClr val="FFFFFF"/>
+                </a:solidFill>
+                <a:latin typeface="Segoe UI"/>
+              </a:rPr>
+              <a:t>Agentic AI design pattern compliance
+[Agents orchestration, routing protocols,
+MCP Servers, Skills, etc]</a:t>
+            </a:r>
+          </a:p>
+        </p:txBody>
+      </p:sp>
+      <p:sp>
+        <p:nvSpPr>
+          <p:cNvPr id="42" name="TextBox 41"/>
+          <p:cNvSpPr txBox="1"/>
+          <p:nvPr/>
+        </p:nvSpPr>
+        <p:spPr>
+          <a:xfrm>
+            <a:off x="3584448" y="4187952"/>
+            <a:ext cx="5056632" cy="768096"/>
+          </a:xfrm>
+          <a:prstGeom prst="rect">
+            <a:avLst/>
+          </a:prstGeom>
+          <a:noFill/>
+        </p:spPr>
+        <p:txBody>
+          <a:bodyPr wrap="square">
+            <a:spAutoFit/>
+          </a:bodyPr>
+          <a:lstStyle/>
+          <a:p>
+            <a:pPr algn="l"/>
+            <a:r>
+              <a:rPr sz="819" b="0" i="0">
+                <a:solidFill>
+                  <a:srgbClr val="B8D0EC"/>
+                </a:solidFill>
+                <a:latin typeface="Segoe UI"/>
+              </a:rPr>
+              <a:t>- Inter-agent handoff efficiency
+- Twin simulation accuracy
+- Tool and skill reusability
+- MCP Server usage relevancy</a:t>
+            </a:r>
+          </a:p>
+        </p:txBody>
+      </p:sp>
+      <p:sp>
+        <p:nvSpPr>
+          <p:cNvPr id="43" name="Rectangle 42"/>
+          <p:cNvSpPr/>
+          <p:nvPr/>
+        </p:nvSpPr>
+        <p:spPr>
+          <a:xfrm>
+            <a:off x="320040" y="5010912"/>
+            <a:ext cx="3063240" cy="1078992"/>
+          </a:xfrm>
+          <a:prstGeom prst="rect">
+            <a:avLst/>
+          </a:prstGeom>
+          <a:solidFill>
+            <a:srgbClr val="0F2845"/>
+          </a:solidFill>
+          <a:ln>
+            <a:noFill/>
+          </a:ln>
+        </p:spPr>
+        <p:style>
+          <a:lnRef idx="1">
+            <a:schemeClr val="accent1"/>
+          </a:lnRef>
+          <a:fillRef idx="3">
+            <a:schemeClr val="accent1"/>
+          </a:fillRef>
+          <a:effectRef idx="2">
+            <a:schemeClr val="accent1"/>
+          </a:effectRef>
+          <a:fontRef idx="minor">
+            <a:schemeClr val="lt1"/>
+          </a:fontRef>
+        </p:style>
+        <p:txBody>
+          <a:bodyPr rtlCol="0" anchor="ctr"/>
+          <a:lstStyle/>
+          <a:p>
+            <a:pPr algn="ctr"/>
+          </a:p>
+        </p:txBody>
+      </p:sp>
+      <p:sp>
+        <p:nvSpPr>
+          <p:cNvPr id="44" name="Rectangle 43"/>
+          <p:cNvSpPr/>
+          <p:nvPr/>
+        </p:nvSpPr>
+        <p:spPr>
+          <a:xfrm>
+            <a:off x="3383280" y="5010912"/>
+            <a:ext cx="5440680" cy="1078992"/>
+          </a:xfrm>
+          <a:prstGeom prst="rect">
+            <a:avLst/>
+          </a:prstGeom>
+          <a:solidFill>
+            <a:srgbClr val="0F2845"/>
+          </a:solidFill>
+          <a:ln>
+            <a:noFill/>
+          </a:ln>
+        </p:spPr>
+        <p:style>
+          <a:lnRef idx="1">
+            <a:schemeClr val="accent1"/>
+          </a:lnRef>
+          <a:fillRef idx="3">
+            <a:schemeClr val="accent1"/>
+          </a:fillRef>
+          <a:effectRef idx="2">
+            <a:schemeClr val="accent1"/>
+          </a:effectRef>
+          <a:fontRef idx="minor">
+            <a:schemeClr val="lt1"/>
+          </a:fontRef>
+        </p:style>
+        <p:txBody>
+          <a:bodyPr rtlCol="0" anchor="ctr"/>
+          <a:lstStyle/>
+          <a:p>
+            <a:pPr algn="ctr"/>
+          </a:p>
+        </p:txBody>
+      </p:sp>
+      <p:sp>
+        <p:nvSpPr>
+          <p:cNvPr id="45" name="Rectangle 44"/>
+          <p:cNvSpPr/>
+          <p:nvPr/>
+        </p:nvSpPr>
+        <p:spPr>
+          <a:xfrm>
+            <a:off x="320040" y="5010912"/>
+            <a:ext cx="50292" cy="1078992"/>
+          </a:xfrm>
+          <a:prstGeom prst="rect">
+            <a:avLst/>
+          </a:prstGeom>
+          <a:solidFill>
+            <a:srgbClr val="00C8F0"/>
+          </a:solidFill>
+          <a:ln>
+            <a:noFill/>
+          </a:ln>
+        </p:spPr>
+        <p:style>
+          <a:lnRef idx="1">
+            <a:schemeClr val="accent1"/>
+          </a:lnRef>
+          <a:fillRef idx="3">
+            <a:schemeClr val="accent1"/>
+          </a:fillRef>
+          <a:effectRef idx="2">
+            <a:schemeClr val="accent1"/>
+          </a:effectRef>
+          <a:fontRef idx="minor">
+            <a:schemeClr val="lt1"/>
+          </a:fontRef>
+        </p:style>
+        <p:txBody>
+          <a:bodyPr rtlCol="0" anchor="ctr"/>
+          <a:lstStyle/>
+          <a:p>
+            <a:pPr algn="ctr"/>
+          </a:p>
+        </p:txBody>
+      </p:sp>
+      <p:sp>
+        <p:nvSpPr>
+          <p:cNvPr id="46" name="Rectangle 45"/>
+          <p:cNvSpPr/>
+          <p:nvPr/>
+        </p:nvSpPr>
+        <p:spPr>
+          <a:xfrm>
+            <a:off x="3383280" y="5010912"/>
+            <a:ext cx="20116" cy="1078992"/>
+          </a:xfrm>
+          <a:prstGeom prst="rect">
+            <a:avLst/>
+          </a:prstGeom>
+          <a:solidFill>
+            <a:srgbClr val="204A70"/>
+          </a:solidFill>
+          <a:ln>
+            <a:noFill/>
+          </a:ln>
+        </p:spPr>
+        <p:style>
+          <a:lnRef idx="1">
+            <a:schemeClr val="accent1"/>
+          </a:lnRef>
+          <a:fillRef idx="3">
+            <a:schemeClr val="accent1"/>
+          </a:fillRef>
+          <a:effectRef idx="2">
+            <a:schemeClr val="accent1"/>
+          </a:effectRef>
+          <a:fontRef idx="minor">
+            <a:schemeClr val="lt1"/>
+          </a:fontRef>
+        </p:style>
+        <p:txBody>
+          <a:bodyPr rtlCol="0" anchor="ctr"/>
+          <a:lstStyle/>
+          <a:p>
+            <a:pPr algn="ctr"/>
+          </a:p>
+        </p:txBody>
+      </p:sp>
+      <p:sp>
+        <p:nvSpPr>
+          <p:cNvPr id="47" name="Rectangle 46"/>
+          <p:cNvSpPr/>
+          <p:nvPr/>
+        </p:nvSpPr>
+        <p:spPr>
+          <a:xfrm>
+            <a:off x="320040" y="5010912"/>
+            <a:ext cx="8503920" cy="10972"/>
+          </a:xfrm>
+          <a:prstGeom prst="rect">
+            <a:avLst/>
+          </a:prstGeom>
+          <a:solidFill>
+            <a:srgbClr val="204A70"/>
+          </a:solidFill>
+          <a:ln>
+            <a:noFill/>
+          </a:ln>
+        </p:spPr>
+        <p:style>
+          <a:lnRef idx="1">
+            <a:schemeClr val="accent1"/>
+          </a:lnRef>
+          <a:fillRef idx="3">
+            <a:schemeClr val="accent1"/>
+          </a:fillRef>
+          <a:effectRef idx="2">
+            <a:schemeClr val="accent1"/>
+          </a:effectRef>
+          <a:fontRef idx="minor">
+            <a:schemeClr val="lt1"/>
+          </a:fontRef>
+        </p:style>
+        <p:txBody>
+          <a:bodyPr rtlCol="0" anchor="ctr"/>
+          <a:lstStyle/>
+          <a:p>
+            <a:pPr algn="ctr"/>
+          </a:p>
+        </p:txBody>
+      </p:sp>
+      <p:sp>
+        <p:nvSpPr>
+          <p:cNvPr id="48" name="TextBox 47"/>
+          <p:cNvSpPr txBox="1"/>
+          <p:nvPr/>
+        </p:nvSpPr>
+        <p:spPr>
+          <a:xfrm>
+            <a:off x="484632" y="5120640"/>
+            <a:ext cx="2743200" cy="914400"/>
+          </a:xfrm>
+          <a:prstGeom prst="rect">
+            <a:avLst/>
+          </a:prstGeom>
+          <a:noFill/>
+        </p:spPr>
+        <p:txBody>
+          <a:bodyPr wrap="square">
+            <a:spAutoFit/>
+          </a:bodyPr>
+          <a:lstStyle/>
+          <a:p>
+            <a:pPr algn="l"/>
+            <a:r>
+              <a:rPr sz="830" b="1" i="0">
+                <a:solidFill>
+                  <a:srgbClr val="FFFFFF"/>
+                </a:solidFill>
+                <a:latin typeface="Segoe UI"/>
+              </a:rPr>
+              <a:t>LLM selection strategies
+[GitHub Copilot &amp; OpenAI] &amp; AI Token
+usage Optimization
+[LLM selection, Context Management,
+and Prompt engineering]</a:t>
+            </a:r>
+          </a:p>
+        </p:txBody>
+      </p:sp>
+      <p:sp>
+        <p:nvSpPr>
+          <p:cNvPr id="49" name="TextBox 48"/>
+          <p:cNvSpPr txBox="1"/>
+          <p:nvPr/>
+        </p:nvSpPr>
+        <p:spPr>
+          <a:xfrm>
+            <a:off x="3584448" y="5120640"/>
+            <a:ext cx="5056632" cy="914400"/>
+          </a:xfrm>
+          <a:prstGeom prst="rect">
+            <a:avLst/>
+          </a:prstGeom>
+          <a:noFill/>
+        </p:spPr>
+        <p:txBody>
+          <a:bodyPr wrap="square">
+            <a:spAutoFit/>
+          </a:bodyPr>
+          <a:lstStyle/>
+          <a:p>
+            <a:pPr algn="l"/>
+            <a:r>
+              <a:rPr sz="819" b="0" i="0">
+                <a:solidFill>
+                  <a:srgbClr val="B8D0EC"/>
+                </a:solidFill>
+                <a:latin typeface="Segoe UI"/>
+              </a:rPr>
+              <a:t>- Token reduction percentage [baseline vs actual]
+- Cost-per-request savings
+- Tool-calling JSON accuracy
+- Prompt caching utilization</a:t>
+            </a:r>
+          </a:p>
+        </p:txBody>
+      </p:sp>
+      <p:sp>
+        <p:nvSpPr>
+          <p:cNvPr id="50" name="Rounded Rectangle 49"/>
+          <p:cNvSpPr/>
+          <p:nvPr/>
+        </p:nvSpPr>
+        <p:spPr>
+          <a:xfrm>
+            <a:off x="320040" y="6272784"/>
+            <a:ext cx="8503920" cy="219456"/>
+          </a:xfrm>
+          <a:prstGeom prst="roundRect">
+            <a:avLst/>
+          </a:prstGeom>
+          <a:solidFill>
+            <a:srgbClr val="0E2A4A"/>
+          </a:solidFill>
+          <a:ln>
+            <a:noFill/>
+          </a:ln>
+        </p:spPr>
+        <p:style>
+          <a:lnRef idx="1">
+            <a:schemeClr val="accent1"/>
+          </a:lnRef>
+          <a:fillRef idx="3">
+            <a:schemeClr val="accent1"/>
+          </a:fillRef>
+          <a:effectRef idx="2">
+            <a:schemeClr val="accent1"/>
+          </a:effectRef>
+          <a:fontRef idx="minor">
+            <a:schemeClr val="lt1"/>
+          </a:fontRef>
+        </p:style>
+        <p:txBody>
+          <a:bodyPr rtlCol="0" anchor="ctr"/>
+          <a:lstStyle/>
+          <a:p>
+            <a:pPr algn="ctr"/>
+          </a:p>
+        </p:txBody>
+      </p:sp>
+      <p:sp>
+        <p:nvSpPr>
+          <p:cNvPr id="51" name="TextBox 50"/>
+          <p:cNvSpPr txBox="1"/>
+          <p:nvPr/>
+        </p:nvSpPr>
+        <p:spPr>
+          <a:xfrm>
+            <a:off x="502920" y="6318504"/>
+            <a:ext cx="8138160" cy="73152"/>
+          </a:xfrm>
+          <a:prstGeom prst="rect">
+            <a:avLst/>
+          </a:prstGeom>
+          <a:noFill/>
+        </p:spPr>
+        <p:txBody>
+          <a:bodyPr wrap="square">
+            <a:spAutoFit/>
+          </a:bodyPr>
+          <a:lstStyle/>
+          <a:p>
+            <a:pPr algn="ctr"/>
+            <a:r>
+              <a:rPr sz="760" b="1" i="0">
+                <a:solidFill>
+                  <a:srgbClr val="00D48A"/>
+                </a:solidFill>
+                <a:latin typeface="Segoe UI"/>
+              </a:rPr>
+              <a:t>FOCUS: prove measurable PDLC impact with a reusable, hosted, agentic-AI execution pattern.</a:t>
+            </a:r>
+          </a:p>
+        </p:txBody>
+      </p:sp>
+      <p:sp>
+        <p:nvSpPr>
+          <p:cNvPr id="52" name="Rectangle 51"/>
+          <p:cNvSpPr/>
+          <p:nvPr/>
+        </p:nvSpPr>
+        <p:spPr>
+          <a:xfrm>
+            <a:off x="0" y="6473952"/>
+            <a:ext cx="9144000" cy="384048"/>
+          </a:xfrm>
+          <a:prstGeom prst="rect">
+            <a:avLst/>
+          </a:prstGeom>
+          <a:solidFill>
+            <a:srgbClr val="0E2A4A"/>
+          </a:solidFill>
+          <a:ln>
+            <a:noFill/>
+          </a:ln>
+        </p:spPr>
+        <p:style>
+          <a:lnRef idx="1">
+            <a:schemeClr val="accent1"/>
+          </a:lnRef>
+          <a:fillRef idx="3">
+            <a:schemeClr val="accent1"/>
+          </a:fillRef>
+          <a:effectRef idx="2">
+            <a:schemeClr val="accent1"/>
+          </a:effectRef>
+          <a:fontRef idx="minor">
+            <a:schemeClr val="lt1"/>
+          </a:fontRef>
+        </p:style>
+        <p:txBody>
+          <a:bodyPr rtlCol="0" anchor="ctr"/>
+          <a:lstStyle/>
+          <a:p>
+            <a:pPr algn="ctr"/>
+          </a:p>
+        </p:txBody>
+      </p:sp>
+      <p:sp>
+        <p:nvSpPr>
+          <p:cNvPr id="53" name="TextBox 52"/>
+          <p:cNvSpPr txBox="1"/>
+          <p:nvPr/>
+        </p:nvSpPr>
+        <p:spPr>
+          <a:xfrm>
+            <a:off x="8321040" y="6510528"/>
+            <a:ext cx="731520" cy="274320"/>
+          </a:xfrm>
+          <a:prstGeom prst="rect">
+            <a:avLst/>
+          </a:prstGeom>
+          <a:noFill/>
+        </p:spPr>
+        <p:txBody>
+          <a:bodyPr wrap="square">
+            <a:spAutoFit/>
+          </a:bodyPr>
+          <a:lstStyle/>
+          <a:p>
+            <a:pPr algn="r"/>
+            <a:r>
+              <a:rPr sz="900" b="0" i="0">
+                <a:solidFill>
+                  <a:srgbClr val="6080A8"/>
+                </a:solidFill>
+                <a:latin typeface="Segoe UI"/>
+              </a:rPr>
+              <a:t>12  /  13</a:t>
+            </a:r>
+          </a:p>
+        </p:txBody>
+      </p:sp>
+    </p:spTree>
+  </p:cSld>
+  <p:clrMapOvr>
+    <a:masterClrMapping/>
+  </p:clrMapOvr>
+</p:sld>
+</file>
+
+<file path=ppt/slides/slide13.xml><?xml version="1.0" encoding="utf-8"?>
+<p:sld xmlns:a="http://schemas.openxmlformats.org/drawingml/2006/main" xmlns:p="http://schemas.openxmlformats.org/presentationml/2006/main" xmlns:r="http://schemas.openxmlformats.org/officeDocument/2006/relationships">
+  <p:cSld>
+    <p:spTree>
+      <p:nvGrpSpPr>
+        <p:cNvPr id="1" name=""/>
+        <p:cNvGrpSpPr/>
+        <p:nvPr/>
+      </p:nvGrpSpPr>
+      <p:grpSpPr/>
+      <p:sp>
+        <p:nvSpPr>
+          <p:cNvPr id="2" name="Rectangle 1"/>
+          <p:cNvSpPr/>
+          <p:nvPr/>
+        </p:nvSpPr>
+        <p:spPr>
+          <a:xfrm>
+            <a:off x="0" y="0"/>
+            <a:ext cx="9144000" cy="6858000"/>
+          </a:xfrm>
+          <a:prstGeom prst="rect">
+            <a:avLst/>
+          </a:prstGeom>
+          <a:solidFill>
+            <a:srgbClr val="020A1A"/>
+          </a:solidFill>
+          <a:ln>
+            <a:noFill/>
+          </a:ln>
+        </p:spPr>
+        <p:style>
+          <a:lnRef idx="1">
+            <a:schemeClr val="accent1"/>
+          </a:lnRef>
+          <a:fillRef idx="3">
+            <a:schemeClr val="accent1"/>
+          </a:fillRef>
+          <a:effectRef idx="2">
+            <a:schemeClr val="accent1"/>
+          </a:effectRef>
+          <a:fontRef idx="minor">
+            <a:schemeClr val="lt1"/>
+          </a:fontRef>
+        </p:style>
+        <p:txBody>
+          <a:bodyPr rtlCol="0" anchor="ctr"/>
+          <a:lstStyle/>
+          <a:p>
+            <a:pPr algn="ctr"/>
+          </a:p>
+        </p:txBody>
+      </p:sp>
+      <p:sp>
+        <p:nvSpPr>
+          <p:cNvPr id="3" name="Rectangle 2"/>
+          <p:cNvSpPr/>
+          <p:nvPr/>
+        </p:nvSpPr>
+        <p:spPr>
+          <a:xfrm>
+            <a:off x="0" y="0"/>
+            <a:ext cx="9144000" cy="50292"/>
+          </a:xfrm>
+          <a:prstGeom prst="rect">
+            <a:avLst/>
+          </a:prstGeom>
+          <a:solidFill>
+            <a:srgbClr val="00C8F0"/>
+          </a:solidFill>
+          <a:ln>
+            <a:noFill/>
+          </a:ln>
+        </p:spPr>
+        <p:style>
+          <a:lnRef idx="1">
+            <a:schemeClr val="accent1"/>
+          </a:lnRef>
+          <a:fillRef idx="3">
+            <a:schemeClr val="accent1"/>
+          </a:fillRef>
+          <a:effectRef idx="2">
+            <a:schemeClr val="accent1"/>
+          </a:effectRef>
+          <a:fontRef idx="minor">
+            <a:schemeClr val="lt1"/>
+          </a:fontRef>
+        </p:style>
+        <p:txBody>
+          <a:bodyPr rtlCol="0" anchor="ctr"/>
+          <a:lstStyle/>
+          <a:p>
+            <a:pPr algn="ctr"/>
+          </a:p>
+        </p:txBody>
+      </p:sp>
+      <p:sp>
+        <p:nvSpPr>
           <p:cNvPr id="4" name="Oval 3"/>
           <p:cNvSpPr/>
           <p:nvPr/>
@@ -23186,7 +25319,7 @@
                 </a:solidFill>
                 <a:latin typeface="Segoe UI"/>
               </a:rPr>
-              <a:t>12  /  12</a:t>
+              <a:t>13  /  13</a:t>
             </a:r>
           </a:p>
         </p:txBody>
@@ -24969,7 +27102,7 @@
                 </a:solidFill>
                 <a:latin typeface="Segoe UI"/>
               </a:rPr>
-              <a:t>2  /  12</a:t>
+              <a:t>2  /  13</a:t>
             </a:r>
           </a:p>
         </p:txBody>
@@ -32765,7 +34898,7 @@
                 </a:solidFill>
                 <a:latin typeface="Segoe UI"/>
               </a:rPr>
-              <a:t>3  /  12</a:t>
+              <a:t>3  /  13</a:t>
             </a:r>
           </a:p>
         </p:txBody>
@@ -34477,7 +36610,7 @@
                 </a:solidFill>
                 <a:latin typeface="Segoe UI"/>
               </a:rPr>
-              <a:t>4  /  12</a:t>
+              <a:t>4  /  13</a:t>
             </a:r>
           </a:p>
         </p:txBody>
@@ -38445,7 +40578,7 @@
                 </a:solidFill>
                 <a:latin typeface="Segoe UI"/>
               </a:rPr>
-              <a:t>5  /  12</a:t>
+              <a:t>5  /  13</a:t>
             </a:r>
           </a:p>
         </p:txBody>
@@ -40313,7 +42446,7 @@
                 </a:solidFill>
                 <a:latin typeface="Segoe UI"/>
               </a:rPr>
-              <a:t>6  /  12</a:t>
+              <a:t>6  /  13</a:t>
             </a:r>
           </a:p>
         </p:txBody>
@@ -43923,7 +46056,7 @@
                 </a:solidFill>
                 <a:latin typeface="Segoe UI"/>
               </a:rPr>
-              <a:t>7  /  12</a:t>
+              <a:t>7  /  13</a:t>
             </a:r>
           </a:p>
         </p:txBody>
@@ -45635,7 +47768,7 @@
                 </a:solidFill>
                 <a:latin typeface="Segoe UI"/>
               </a:rPr>
-              <a:t>8  /  12</a:t>
+              <a:t>8  /  13</a:t>
             </a:r>
           </a:p>
         </p:txBody>
@@ -46917,7 +49050,7 @@
                 </a:solidFill>
                 <a:latin typeface="Segoe UI"/>
               </a:rPr>
-              <a:t>9  /  12</a:t>
+              <a:t>9  /  13</a:t>
             </a:r>
           </a:p>
         </p:txBody>

</xml_diff>